<commit_message>
added stufy 2 to poster
</commit_message>
<xml_diff>
--- a/poster.pptx
+++ b/poster.pptx
@@ -2994,6 +2994,53 @@
       </p:grpSpPr>
       <p:pic>
         <p:nvPicPr>
+          <p:cNvPr id="1030" name="Picture 6">
+            <a:extLst>
+              <a:ext uri="{FF2B5EF4-FFF2-40B4-BE49-F238E27FC236}">
+                <a16:creationId xmlns:a16="http://schemas.microsoft.com/office/drawing/2014/main" id="{526F8B55-AE78-0DCB-4A57-393747C15331}"/>
+              </a:ext>
+            </a:extLst>
+          </p:cNvPr>
+          <p:cNvPicPr>
+            <a:picLocks noChangeAspect="1" noChangeArrowheads="1"/>
+          </p:cNvPicPr>
+          <p:nvPr/>
+        </p:nvPicPr>
+        <p:blipFill>
+          <a:blip r:embed="rId2">
+            <a:extLst>
+              <a:ext uri="{28A0092B-C50C-407E-A947-70E740481C1C}">
+                <a14:useLocalDpi xmlns:a14="http://schemas.microsoft.com/office/drawing/2010/main" val="0"/>
+              </a:ext>
+            </a:extLst>
+          </a:blip>
+          <a:srcRect/>
+          <a:stretch>
+            <a:fillRect/>
+          </a:stretch>
+        </p:blipFill>
+        <p:spPr bwMode="auto">
+          <a:xfrm>
+            <a:off x="10985842" y="14303048"/>
+            <a:ext cx="2160000" cy="2160000"/>
+          </a:xfrm>
+          <a:prstGeom prst="rect">
+            <a:avLst/>
+          </a:prstGeom>
+          <a:noFill/>
+          <a:extLst>
+            <a:ext uri="{909E8E84-426E-40DD-AFC4-6F175D3DCCD1}">
+              <a14:hiddenFill xmlns:a14="http://schemas.microsoft.com/office/drawing/2010/main">
+                <a:solidFill>
+                  <a:srgbClr val="FFFFFF"/>
+                </a:solidFill>
+              </a14:hiddenFill>
+            </a:ext>
+          </a:extLst>
+        </p:spPr>
+      </p:pic>
+      <p:pic>
+        <p:nvPicPr>
           <p:cNvPr id="1032" name="Picture 8">
             <a:extLst>
               <a:ext uri="{FF2B5EF4-FFF2-40B4-BE49-F238E27FC236}">
@@ -3007,7 +3054,7 @@
           <p:nvPr/>
         </p:nvPicPr>
         <p:blipFill>
-          <a:blip r:embed="rId2">
+          <a:blip r:embed="rId3">
             <a:extLst>
               <a:ext uri="{28A0092B-C50C-407E-A947-70E740481C1C}">
                 <a14:useLocalDpi xmlns:a14="http://schemas.microsoft.com/office/drawing/2010/main" val="0"/>
@@ -3054,7 +3101,7 @@
           <p:nvPr/>
         </p:nvPicPr>
         <p:blipFill>
-          <a:blip r:embed="rId3">
+          <a:blip r:embed="rId4">
             <a:extLst>
               <a:ext uri="{28A0092B-C50C-407E-A947-70E740481C1C}">
                 <a14:useLocalDpi xmlns:a14="http://schemas.microsoft.com/office/drawing/2010/main" val="0"/>
@@ -3101,7 +3148,7 @@
           <p:nvPr/>
         </p:nvPicPr>
         <p:blipFill>
-          <a:blip r:embed="rId4">
+          <a:blip r:embed="rId5">
             <a:extLst>
               <a:ext uri="{28A0092B-C50C-407E-A947-70E740481C1C}">
                 <a14:useLocalDpi xmlns:a14="http://schemas.microsoft.com/office/drawing/2010/main" val="0"/>
@@ -3285,15 +3332,12 @@
             <a:pPr algn="ctr"/>
             <a:r>
               <a:rPr lang="en-GB" sz="3200" dirty="0">
-                <a:hlinkClick r:id="rId5"/>
+                <a:solidFill>
+                  <a:srgbClr val="000066"/>
+                </a:solidFill>
               </a:rPr>
               <a:t>https://en.wikipedia.org/wiki/Genetic_algorithm</a:t>
             </a:r>
-            <a:endParaRPr lang="en-GB" sz="3200" dirty="0">
-              <a:solidFill>
-                <a:schemeClr val="tx1"/>
-              </a:solidFill>
-            </a:endParaRPr>
           </a:p>
           <a:p>
             <a:pPr algn="ctr"/>
@@ -3326,15 +3370,12 @@
             <a:pPr algn="ctr"/>
             <a:r>
               <a:rPr lang="en-GB" sz="3200" dirty="0">
-                <a:hlinkClick r:id="rId6"/>
+                <a:solidFill>
+                  <a:srgbClr val="000066"/>
+                </a:solidFill>
               </a:rPr>
               <a:t>https://en.wikipedia.org/wiki/Computational_fluid_dynamics</a:t>
             </a:r>
-            <a:endParaRPr lang="en-GB" sz="3200" dirty="0">
-              <a:solidFill>
-                <a:schemeClr val="tx1"/>
-              </a:solidFill>
-            </a:endParaRPr>
           </a:p>
         </p:txBody>
       </p:sp>
@@ -3972,7 +4013,15 @@
           </a:p>
           <a:p>
             <a:pPr algn="ctr"/>
-            <a:endParaRPr lang="en-GB" sz="3200" dirty="0">
+            <a:endParaRPr lang="en-GB" sz="1100" dirty="0">
+              <a:solidFill>
+                <a:schemeClr val="tx1"/>
+              </a:solidFill>
+            </a:endParaRPr>
+          </a:p>
+          <a:p>
+            <a:pPr algn="ctr"/>
+            <a:endParaRPr lang="en-GB" sz="1100" dirty="0">
               <a:solidFill>
                 <a:schemeClr val="tx1"/>
               </a:solidFill>
@@ -4246,7 +4295,7 @@
           <p:nvPr/>
         </p:nvPicPr>
         <p:blipFill>
-          <a:blip r:embed="rId7">
+          <a:blip r:embed="rId6">
             <a:extLst>
               <a:ext uri="{28A0092B-C50C-407E-A947-70E740481C1C}">
                 <a14:useLocalDpi xmlns:a14="http://schemas.microsoft.com/office/drawing/2010/main" val="0"/>
@@ -4260,55 +4309,8 @@
         </p:blipFill>
         <p:spPr bwMode="auto">
           <a:xfrm>
-            <a:off x="845436" y="9419970"/>
+            <a:off x="845625" y="9419970"/>
             <a:ext cx="9000000" cy="3000000"/>
-          </a:xfrm>
-          <a:prstGeom prst="rect">
-            <a:avLst/>
-          </a:prstGeom>
-          <a:noFill/>
-          <a:extLst>
-            <a:ext uri="{909E8E84-426E-40DD-AFC4-6F175D3DCCD1}">
-              <a14:hiddenFill xmlns:a14="http://schemas.microsoft.com/office/drawing/2010/main">
-                <a:solidFill>
-                  <a:srgbClr val="FFFFFF"/>
-                </a:solidFill>
-              </a14:hiddenFill>
-            </a:ext>
-          </a:extLst>
-        </p:spPr>
-      </p:pic>
-      <p:pic>
-        <p:nvPicPr>
-          <p:cNvPr id="1030" name="Picture 6">
-            <a:extLst>
-              <a:ext uri="{FF2B5EF4-FFF2-40B4-BE49-F238E27FC236}">
-                <a16:creationId xmlns:a16="http://schemas.microsoft.com/office/drawing/2014/main" id="{526F8B55-AE78-0DCB-4A57-393747C15331}"/>
-              </a:ext>
-            </a:extLst>
-          </p:cNvPr>
-          <p:cNvPicPr>
-            <a:picLocks noChangeAspect="1" noChangeArrowheads="1"/>
-          </p:cNvPicPr>
-          <p:nvPr/>
-        </p:nvPicPr>
-        <p:blipFill>
-          <a:blip r:embed="rId8">
-            <a:extLst>
-              <a:ext uri="{28A0092B-C50C-407E-A947-70E740481C1C}">
-                <a14:useLocalDpi xmlns:a14="http://schemas.microsoft.com/office/drawing/2010/main" val="0"/>
-              </a:ext>
-            </a:extLst>
-          </a:blip>
-          <a:srcRect/>
-          <a:stretch>
-            <a:fillRect/>
-          </a:stretch>
-        </p:blipFill>
-        <p:spPr bwMode="auto">
-          <a:xfrm>
-            <a:off x="10985842" y="14303048"/>
-            <a:ext cx="2160000" cy="2160000"/>
           </a:xfrm>
           <a:prstGeom prst="rect">
             <a:avLst/>
@@ -4771,7 +4773,7 @@
           <p:nvPr>
             <p:extLst>
               <p:ext uri="{D42A27DB-BD31-4B8C-83A1-F6EECF244321}">
-                <p14:modId xmlns:p14="http://schemas.microsoft.com/office/powerpoint/2010/main" val="2964681958"/>
+                <p14:modId xmlns:p14="http://schemas.microsoft.com/office/powerpoint/2010/main" val="4282257347"/>
               </p:ext>
             </p:extLst>
           </p:nvPr>
@@ -5122,11 +5124,14 @@
                     <a:bodyPr/>
                     <a:lstStyle/>
                     <a:p>
-                      <a:endParaRPr lang="en-GB" sz="3200" dirty="0">
-                        <a:solidFill>
-                          <a:schemeClr val="bg1"/>
-                        </a:solidFill>
-                      </a:endParaRPr>
+                      <a:r>
+                        <a:rPr lang="en-GB" sz="3200" dirty="0">
+                          <a:solidFill>
+                            <a:schemeClr val="bg1"/>
+                          </a:solidFill>
+                        </a:rPr>
+                        <a:t>494</a:t>
+                      </a:r>
                     </a:p>
                   </a:txBody>
                   <a:tcPr>
@@ -5627,7 +5632,7 @@
           <p:nvPr/>
         </p:nvPicPr>
         <p:blipFill>
-          <a:blip r:embed="rId9">
+          <a:blip r:embed="rId7">
             <a:extLst>
               <a:ext uri="{28A0092B-C50C-407E-A947-70E740481C1C}">
                 <a14:useLocalDpi xmlns:a14="http://schemas.microsoft.com/office/drawing/2010/main" val="0"/>
@@ -5657,6 +5662,36 @@
               </a14:hiddenFill>
             </a:ext>
           </a:extLst>
+        </p:spPr>
+      </p:pic>
+      <p:pic>
+        <p:nvPicPr>
+          <p:cNvPr id="2" name="Picture 1" descr="points.png">
+            <a:extLst>
+              <a:ext uri="{FF2B5EF4-FFF2-40B4-BE49-F238E27FC236}">
+                <a16:creationId xmlns:a16="http://schemas.microsoft.com/office/drawing/2014/main" id="{1FDC10CA-218A-215F-9694-D3920F58F1CD}"/>
+              </a:ext>
+            </a:extLst>
+          </p:cNvPr>
+          <p:cNvPicPr>
+            <a:picLocks noChangeAspect="1"/>
+          </p:cNvPicPr>
+          <p:nvPr/>
+        </p:nvPicPr>
+        <p:blipFill>
+          <a:blip r:embed="rId8"/>
+          <a:stretch>
+            <a:fillRect/>
+          </a:stretch>
+        </p:blipFill>
+        <p:spPr>
+          <a:xfrm>
+            <a:off x="11536311" y="9419970"/>
+            <a:ext cx="9000000" cy="3000000"/>
+          </a:xfrm>
+          <a:prstGeom prst="rect">
+            <a:avLst/>
+          </a:prstGeom>
         </p:spPr>
       </p:pic>
     </p:spTree>

</xml_diff>